<commit_message>
added reference to this repo
</commit_message>
<xml_diff>
--- a/lectures/01_introduction/01_introduction.pptx
+++ b/lectures/01_introduction/01_introduction.pptx
@@ -152,7 +152,7 @@
 <file path=ppt/revisionInfo.xml><?xml version="1.0" encoding="utf-8"?>
 <p1510:revInfo xmlns:a="http://schemas.openxmlformats.org/drawingml/2006/main" xmlns:r="http://schemas.openxmlformats.org/officeDocument/2006/relationships" xmlns:p1510="http://schemas.microsoft.com/office/powerpoint/2015/10/main">
   <p1510:revLst>
-    <p1510:client id="{723D3D62-20B4-2D79-B606-6A831C205B00}" v="390" dt="2026-02-10T12:28:32.287"/>
+    <p1510:client id="{A92A0ADB-D548-B13B-8342-E4F32DD1252A}" v="58" dt="2026-02-24T10:45:49.412"/>
   </p1510:revLst>
 </p1510:revInfo>
 </file>
@@ -41579,7 +41579,75 @@
               <a:buFont typeface="Arial"/>
               <a:buChar char="•"/>
             </a:pPr>
-            <a:endParaRPr lang="en-GB" sz="2000" spc="-1" dirty="0">
+            <a:r>
+              <a:rPr lang="en-GB" sz="2000" spc="-1" dirty="0">
+                <a:solidFill>
+                  <a:srgbClr val="003056"/>
+                </a:solidFill>
+                <a:latin typeface="Calibri"/>
+                <a:ea typeface="Calibri"/>
+                <a:cs typeface="Calibri"/>
+              </a:rPr>
+              <a:t>Official repository with </a:t>
+            </a:r>
+            <a:r>
+              <a:rPr lang="en-GB" sz="2000" b="1" spc="-1" dirty="0">
+                <a:solidFill>
+                  <a:srgbClr val="003056"/>
+                </a:solidFill>
+                <a:latin typeface="Calibri"/>
+                <a:ea typeface="Calibri"/>
+                <a:cs typeface="Calibri"/>
+              </a:rPr>
+              <a:t>all the contents of this course on </a:t>
+            </a:r>
+            <a:r>
+              <a:rPr lang="en-GB" sz="2000" b="1" spc="-1" dirty="0" err="1">
+                <a:solidFill>
+                  <a:srgbClr val="003056"/>
+                </a:solidFill>
+                <a:latin typeface="Calibri"/>
+                <a:ea typeface="Calibri"/>
+                <a:cs typeface="Calibri"/>
+                <a:hlinkClick r:id="rId2"/>
+              </a:rPr>
+              <a:t>Github</a:t>
+            </a:r>
+            <a:endParaRPr lang="en-GB" sz="2000" b="1" spc="-1" dirty="0" err="1">
+              <a:solidFill>
+                <a:srgbClr val="003056"/>
+              </a:solidFill>
+              <a:latin typeface="Calibri"/>
+              <a:ea typeface="Calibri"/>
+              <a:cs typeface="Calibri"/>
+            </a:endParaRPr>
+          </a:p>
+          <a:p>
+            <a:pPr marL="742950" lvl="1" indent="-342900">
+              <a:lnSpc>
+                <a:spcPct val="100000"/>
+              </a:lnSpc>
+              <a:spcBef>
+                <a:spcPts val="360"/>
+              </a:spcBef>
+              <a:buClr>
+                <a:srgbClr val="003056"/>
+              </a:buClr>
+              <a:buFont typeface="Arial"/>
+              <a:buChar char="•"/>
+            </a:pPr>
+            <a:r>
+              <a:rPr lang="en-GB" sz="1800" spc="-1">
+                <a:solidFill>
+                  <a:srgbClr val="003056"/>
+                </a:solidFill>
+                <a:latin typeface="Calibri"/>
+                <a:ea typeface="Calibri"/>
+                <a:cs typeface="Calibri"/>
+              </a:rPr>
+              <a:t>Feel free to explore ahead, see what to expect, study in advance, etc.</a:t>
+            </a:r>
+            <a:endParaRPr lang="en-GB" sz="1800" spc="-1" baseline="-25000" dirty="0">
               <a:solidFill>
                 <a:srgbClr val="003056"/>
               </a:solidFill>
@@ -42169,6 +42237,92 @@
                                           <p:spTgt spid="100">
                                             <p:txEl>
                                               <p:pRg st="9" end="9"/>
+                                            </p:txEl>
+                                          </p:spTgt>
+                                        </p:tgtEl>
+                                      </p:cBhvr>
+                                    </p:animEffect>
+                                  </p:childTnLst>
+                                </p:cTn>
+                              </p:par>
+                              <p:par>
+                                <p:cTn id="39" presetID="22" presetClass="entr" presetSubtype="4" fill="hold" nodeType="withEffect">
+                                  <p:stCondLst>
+                                    <p:cond delay="0"/>
+                                  </p:stCondLst>
+                                  <p:childTnLst>
+                                    <p:set>
+                                      <p:cBhvr>
+                                        <p:cTn id="40" dur="1" fill="hold">
+                                          <p:stCondLst>
+                                            <p:cond delay="0"/>
+                                          </p:stCondLst>
+                                        </p:cTn>
+                                        <p:tgtEl>
+                                          <p:spTgt spid="100">
+                                            <p:txEl>
+                                              <p:pRg st="10" end="10"/>
+                                            </p:txEl>
+                                          </p:spTgt>
+                                        </p:tgtEl>
+                                        <p:attrNameLst>
+                                          <p:attrName>style.visibility</p:attrName>
+                                        </p:attrNameLst>
+                                      </p:cBhvr>
+                                      <p:to>
+                                        <p:strVal val="visible"/>
+                                      </p:to>
+                                    </p:set>
+                                    <p:animEffect transition="in" filter="wipe(down)">
+                                      <p:cBhvr additive="repl">
+                                        <p:cTn id="41" dur="500"/>
+                                        <p:tgtEl>
+                                          <p:spTgt spid="100">
+                                            <p:txEl>
+                                              <p:pRg st="10" end="10"/>
+                                            </p:txEl>
+                                          </p:spTgt>
+                                        </p:tgtEl>
+                                      </p:cBhvr>
+                                    </p:animEffect>
+                                  </p:childTnLst>
+                                </p:cTn>
+                              </p:par>
+                              <p:par>
+                                <p:cTn id="42" presetID="22" presetClass="entr" presetSubtype="4" fill="hold" nodeType="withEffect">
+                                  <p:stCondLst>
+                                    <p:cond delay="0"/>
+                                  </p:stCondLst>
+                                  <p:childTnLst>
+                                    <p:set>
+                                      <p:cBhvr>
+                                        <p:cTn id="43" dur="1" fill="hold">
+                                          <p:stCondLst>
+                                            <p:cond delay="0"/>
+                                          </p:stCondLst>
+                                        </p:cTn>
+                                        <p:tgtEl>
+                                          <p:spTgt spid="100">
+                                            <p:txEl>
+                                              <p:pRg st="11" end="11"/>
+                                            </p:txEl>
+                                          </p:spTgt>
+                                        </p:tgtEl>
+                                        <p:attrNameLst>
+                                          <p:attrName>style.visibility</p:attrName>
+                                        </p:attrNameLst>
+                                      </p:cBhvr>
+                                      <p:to>
+                                        <p:strVal val="visible"/>
+                                      </p:to>
+                                    </p:set>
+                                    <p:animEffect transition="in" filter="wipe(down)">
+                                      <p:cBhvr additive="repl">
+                                        <p:cTn id="44" dur="500"/>
+                                        <p:tgtEl>
+                                          <p:spTgt spid="100">
+                                            <p:txEl>
+                                              <p:pRg st="11" end="11"/>
                                             </p:txEl>
                                           </p:spTgt>
                                         </p:tgtEl>

</xml_diff>